<commit_message>
docs: v1.3 — document the Timeline Reset button + Matrix label_below
DOC-02 User Manual: Reset button added to the Timeline scrubber controls table
and a note on PMBOK's Tools & Techniques band sitting under Inputs & Outputs.
DOC-01 Architecture: `label_below` zone-heading option in the config types, and
the Timeline Reset control in §8.2. DOC-02 summary deck gets a Reset bullet.
DOC-01/02 bumped to v1.3 (+ doc-control rows); README updated. DOC-03 unchanged
(no operational change). Regenerated the affected .docx/.pptx.

Co-Authored-By: Claude Opus 4.8 <noreply@anthropic.com>
</commit_message>
<xml_diff>
--- a/docs/02_User_Manual_Summary.pptx
+++ b/docs/02_User_Manual_Summary.pptx
@@ -5418,6 +5418,25 @@
                 <a:latin typeface="Segoe UI"/>
               </a:rPr>
               <a:t>•  Play to auto-advance; Spotlight one stage, or Cumulative to build up.</a:t>
+            </a:r>
+          </a:p>
+          <a:p>
+            <a:pPr algn="l">
+              <a:spcBef>
+                <a:spcPts val="0"/>
+              </a:spcBef>
+              <a:spcAft>
+                <a:spcPts val="1200"/>
+              </a:spcAft>
+            </a:pPr>
+            <a:r>
+              <a:rPr sz="1700" b="0">
+                <a:solidFill>
+                  <a:srgbClr val="1C2B3A"/>
+                </a:solidFill>
+                <a:latin typeface="Segoe UI"/>
+              </a:rPr>
+              <a:t>•  Reset (gold button) clears the selection and scrubber back to the full view.</a:t>
             </a:r>
           </a:p>
         </p:txBody>

</xml_diff>